<commit_message>
added final poster draft
</commit_message>
<xml_diff>
--- a/Poster.pptx
+++ b/Poster.pptx
@@ -5763,7 +5763,7 @@
                 <a:ea typeface="Lato" panose="020F0502020204030203" pitchFamily="34" charset="0"/>
                 <a:cs typeface="Lato" panose="020F0502020204030203" pitchFamily="34" charset="0"/>
               </a:rPr>
-              <a:t>Figure 1. A “fire” and ”no-fire” image from ”The Wildfire Dataset” [2]. </a:t>
+              <a:t>Figure 1 + 2. A “fire” and ”no-fire” image from ”The Wildfire Dataset” [2]. </a:t>
             </a:r>
             <a:endParaRPr lang="en-US" sz="2800" dirty="0"/>
           </a:p>
@@ -5798,7 +5798,7 @@
         </p:blipFill>
         <p:spPr bwMode="auto">
           <a:xfrm>
-            <a:off x="16145871" y="21797120"/>
+            <a:off x="16145871" y="21652944"/>
             <a:ext cx="15228016" cy="6271795"/>
           </a:xfrm>
           <a:prstGeom prst="rect">
@@ -5845,7 +5845,7 @@
         </p:blipFill>
         <p:spPr bwMode="auto">
           <a:xfrm>
-            <a:off x="1305626" y="28255840"/>
+            <a:off x="1305626" y="27660600"/>
             <a:ext cx="13777885" cy="3599031"/>
           </a:xfrm>
           <a:prstGeom prst="rect">
@@ -6092,7 +6092,7 @@
             </a:r>
             <a:r>
               <a:rPr lang="en-US" sz="4800" dirty="0"/>
-              <a:t> Achieved 82.14% validation accuracy, with moderate overfitting indicated by rising validation loss. Despite regularization (dropout, batch normalization), the model misclassified some samples (82 false positives, 63 false negatives), suggesting potential gains from data augmentation or architecture tuning.</a:t>
+              <a:t> Achieved 82.14% validation accuracy, with moderate overfitting indicated by rising validation loss. Despite regularization the model misclassified some samples (82 false positives, 63 false negatives), suggesting potential gains from data augmentation or architecture tuning.</a:t>
             </a:r>
           </a:p>
         </p:txBody>
@@ -6111,7 +6111,7 @@
         </p:nvSpPr>
         <p:spPr>
           <a:xfrm>
-            <a:off x="15610950" y="28074608"/>
+            <a:off x="15763348" y="28432727"/>
             <a:ext cx="15554850" cy="3785652"/>
           </a:xfrm>
           <a:prstGeom prst="rect">
@@ -6131,8 +6131,107 @@
             </a:r>
             <a:r>
               <a:rPr lang="en-US" sz="4800" dirty="0"/>
-              <a:t> Demonstrated strong learning on training data (R² &gt; 0.7) but failed to generalize (test R² ≈ 0), indicating overfitting and architectural mismatch for the dataset size and quality. Additional regularization and improved feature engineering are needed for better test performance.</a:t>
-            </a:r>
+              <a:t> Demonstrated strong learning on training data  but failed to generalize (test R² ≈ 0), indicating overfitting and architectural mismatch for the dataset size and quality. Additional regularization and improved feature engineering are needed for better test performance.</a:t>
+            </a:r>
+          </a:p>
+        </p:txBody>
+      </p:sp>
+      <p:sp>
+        <p:nvSpPr>
+          <p:cNvPr id="22" name="TextBox 21">
+            <a:extLst>
+              <a:ext uri="{FF2B5EF4-FFF2-40B4-BE49-F238E27FC236}">
+                <a16:creationId xmlns:a16="http://schemas.microsoft.com/office/drawing/2014/main" id="{77821EE0-FE8F-E5C8-85AA-2D95F27B9095}"/>
+              </a:ext>
+            </a:extLst>
+          </p:cNvPr>
+          <p:cNvSpPr txBox="1"/>
+          <p:nvPr/>
+        </p:nvSpPr>
+        <p:spPr>
+          <a:xfrm>
+            <a:off x="16992596" y="27732620"/>
+            <a:ext cx="13777885" cy="523220"/>
+          </a:xfrm>
+          <a:prstGeom prst="rect">
+            <a:avLst/>
+          </a:prstGeom>
+          <a:noFill/>
+        </p:spPr>
+        <p:txBody>
+          <a:bodyPr wrap="square">
+            <a:spAutoFit/>
+          </a:bodyPr>
+          <a:lstStyle/>
+          <a:p>
+            <a:r>
+              <a:rPr lang="en-US" sz="2800" b="0" dirty="0">
+                <a:effectLst/>
+                <a:latin typeface="Lato" panose="020F0502020204030203" pitchFamily="34" charset="0"/>
+                <a:ea typeface="Lato" panose="020F0502020204030203" pitchFamily="34" charset="0"/>
+                <a:cs typeface="Lato" panose="020F0502020204030203" pitchFamily="34" charset="0"/>
+              </a:rPr>
+              <a:t>Figure 3 + 4: Accuracy and loss over epochs for training and validation sets for CNN.</a:t>
+            </a:r>
+            <a:endParaRPr lang="en-US" sz="2800" dirty="0"/>
+          </a:p>
+        </p:txBody>
+      </p:sp>
+      <p:sp>
+        <p:nvSpPr>
+          <p:cNvPr id="27" name="TextBox 26">
+            <a:extLst>
+              <a:ext uri="{FF2B5EF4-FFF2-40B4-BE49-F238E27FC236}">
+                <a16:creationId xmlns:a16="http://schemas.microsoft.com/office/drawing/2014/main" id="{720671EE-D73E-6A6A-68B2-92DBFCC5DBE6}"/>
+              </a:ext>
+            </a:extLst>
+          </p:cNvPr>
+          <p:cNvSpPr txBox="1"/>
+          <p:nvPr/>
+        </p:nvSpPr>
+        <p:spPr>
+          <a:xfrm>
+            <a:off x="1260398" y="31398587"/>
+            <a:ext cx="13777885" cy="523220"/>
+          </a:xfrm>
+          <a:prstGeom prst="rect">
+            <a:avLst/>
+          </a:prstGeom>
+          <a:noFill/>
+        </p:spPr>
+        <p:txBody>
+          <a:bodyPr wrap="square">
+            <a:spAutoFit/>
+          </a:bodyPr>
+          <a:lstStyle/>
+          <a:p>
+            <a:r>
+              <a:rPr lang="en-US" sz="2800" b="0" dirty="0">
+                <a:effectLst/>
+                <a:latin typeface="Lato" panose="020F0502020204030203" pitchFamily="34" charset="0"/>
+                <a:ea typeface="Lato" panose="020F0502020204030203" pitchFamily="34" charset="0"/>
+                <a:cs typeface="Lato" panose="020F0502020204030203" pitchFamily="34" charset="0"/>
+              </a:rPr>
+              <a:t>Figure </a:t>
+            </a:r>
+            <a:r>
+              <a:rPr lang="en-US" sz="2800" dirty="0">
+                <a:latin typeface="Lato" panose="020F0502020204030203" pitchFamily="34" charset="0"/>
+                <a:ea typeface="Lato" panose="020F0502020204030203" pitchFamily="34" charset="0"/>
+                <a:cs typeface="Lato" panose="020F0502020204030203" pitchFamily="34" charset="0"/>
+              </a:rPr>
+              <a:t>5</a:t>
+            </a:r>
+            <a:r>
+              <a:rPr lang="en-US" sz="2800" b="0" dirty="0">
+                <a:effectLst/>
+                <a:latin typeface="Lato" panose="020F0502020204030203" pitchFamily="34" charset="0"/>
+                <a:ea typeface="Lato" panose="020F0502020204030203" pitchFamily="34" charset="0"/>
+                <a:cs typeface="Lato" panose="020F0502020204030203" pitchFamily="34" charset="0"/>
+              </a:rPr>
+              <a:t>: MLP metrics containing loss for training and testing sets and R^2 value.</a:t>
+            </a:r>
+            <a:endParaRPr lang="en-US" sz="2800" dirty="0"/>
           </a:p>
         </p:txBody>
       </p:sp>

</xml_diff>

<commit_message>
quick change in poster
</commit_message>
<xml_diff>
--- a/Poster.pptx
+++ b/Poster.pptx
@@ -5056,7 +5056,7 @@
                 </a:solidFill>
                 <a:latin typeface="+mj-lt"/>
               </a:rPr>
-              <a:t>Results</a:t>
+              <a:t>Results and Discussion</a:t>
             </a:r>
           </a:p>
         </p:txBody>
@@ -7612,10 +7612,17 @@
 <file path=customXml/itemProps1.xml><?xml version="1.0" encoding="utf-8"?>
 <ds:datastoreItem xmlns:ds="http://schemas.openxmlformats.org/officeDocument/2006/customXml" ds:itemID="{EA5F3152-1B22-4120-90AD-ABECC3E883B9}">
   <ds:schemaRefs>
+    <ds:schemaRef ds:uri="http://purl.org/dc/dcmitype/"/>
+    <ds:schemaRef ds:uri="http://purl.org/dc/elements/1.1/"/>
+    <ds:schemaRef ds:uri="http://purl.org/dc/terms/"/>
     <ds:schemaRef ds:uri="http://schemas.microsoft.com/office/2006/metadata/properties"/>
+    <ds:schemaRef ds:uri="http://schemas.openxmlformats.org/package/2006/metadata/core-properties"/>
+    <ds:schemaRef ds:uri="8380694e-df13-4765-9f36-450494b12df9"/>
+    <ds:schemaRef ds:uri="http://schemas.microsoft.com/office/2006/documentManagement/types"/>
+    <ds:schemaRef ds:uri="http://www.w3.org/XML/1998/namespace"/>
     <ds:schemaRef ds:uri="http://schemas.microsoft.com/office/infopath/2007/PartnerControls"/>
+    <ds:schemaRef ds:uri="e9952153-5aa5-42e8-8300-ccc6398e6c31"/>
     <ds:schemaRef ds:uri="251e4a2b-1a33-4513-9017-f0bb34cca31e"/>
-    <ds:schemaRef ds:uri="e9952153-5aa5-42e8-8300-ccc6398e6c31"/>
   </ds:schemaRefs>
 </ds:datastoreItem>
 </file>

</xml_diff>

<commit_message>
added final code versions and updated poster
</commit_message>
<xml_diff>
--- a/Poster.pptx
+++ b/Poster.pptx
@@ -860,7 +860,7 @@
           <a:p>
             <a:fld id="{3E6A3A3A-F046-46B7-AB30-656DBACC10AF}" type="datetimeFigureOut">
               <a:rPr lang="en-US" smtClean="0"/>
-              <a:t>4/12/2025</a:t>
+              <a:t>4/13/2025</a:t>
             </a:fld>
             <a:endParaRPr lang="en-US"/>
           </a:p>
@@ -1025,7 +1025,7 @@
           <a:p>
             <a:fld id="{3BAAEEF9-7578-433F-ACA7-67A4266BF312}" type="datetimeFigureOut">
               <a:rPr lang="en-US" smtClean="0"/>
-              <a:t>4/12/2025</a:t>
+              <a:t>4/13/2025</a:t>
             </a:fld>
             <a:endParaRPr lang="en-US"/>
           </a:p>
@@ -1471,7 +1471,7 @@
           <a:p>
             <a:fld id="{24E1524C-2386-4A77-AA3F-47DF77D98E67}" type="datetimeFigureOut">
               <a:rPr lang="en-US" smtClean="0"/>
-              <a:t>4/12/2025</a:t>
+              <a:t>4/13/2025</a:t>
             </a:fld>
             <a:endParaRPr lang="en-US"/>
           </a:p>
@@ -1751,7 +1751,7 @@
           <a:p>
             <a:fld id="{24E1524C-2386-4A77-AA3F-47DF77D98E67}" type="datetimeFigureOut">
               <a:rPr lang="en-US" smtClean="0"/>
-              <a:t>4/12/2025</a:t>
+              <a:t>4/13/2025</a:t>
             </a:fld>
             <a:endParaRPr lang="en-US"/>
           </a:p>
@@ -1929,7 +1929,7 @@
           <a:p>
             <a:fld id="{24E1524C-2386-4A77-AA3F-47DF77D98E67}" type="datetimeFigureOut">
               <a:rPr lang="en-US" smtClean="0"/>
-              <a:t>4/12/2025</a:t>
+              <a:t>4/13/2025</a:t>
             </a:fld>
             <a:endParaRPr lang="en-US"/>
           </a:p>
@@ -2102,7 +2102,7 @@
           <a:p>
             <a:fld id="{24E1524C-2386-4A77-AA3F-47DF77D98E67}" type="datetimeFigureOut">
               <a:rPr lang="en-US" smtClean="0"/>
-              <a:t>4/12/2025</a:t>
+              <a:t>4/13/2025</a:t>
             </a:fld>
             <a:endParaRPr lang="en-US"/>
           </a:p>
@@ -2347,7 +2347,7 @@
           <a:p>
             <a:fld id="{24E1524C-2386-4A77-AA3F-47DF77D98E67}" type="datetimeFigureOut">
               <a:rPr lang="en-US" smtClean="0"/>
-              <a:t>4/12/2025</a:t>
+              <a:t>4/13/2025</a:t>
             </a:fld>
             <a:endParaRPr lang="en-US"/>
           </a:p>
@@ -2632,7 +2632,7 @@
           <a:p>
             <a:fld id="{24E1524C-2386-4A77-AA3F-47DF77D98E67}" type="datetimeFigureOut">
               <a:rPr lang="en-US" smtClean="0"/>
-              <a:t>4/12/2025</a:t>
+              <a:t>4/13/2025</a:t>
             </a:fld>
             <a:endParaRPr lang="en-US"/>
           </a:p>
@@ -3051,7 +3051,7 @@
           <a:p>
             <a:fld id="{24E1524C-2386-4A77-AA3F-47DF77D98E67}" type="datetimeFigureOut">
               <a:rPr lang="en-US" smtClean="0"/>
-              <a:t>4/12/2025</a:t>
+              <a:t>4/13/2025</a:t>
             </a:fld>
             <a:endParaRPr lang="en-US"/>
           </a:p>
@@ -3168,7 +3168,7 @@
           <a:p>
             <a:fld id="{24E1524C-2386-4A77-AA3F-47DF77D98E67}" type="datetimeFigureOut">
               <a:rPr lang="en-US" smtClean="0"/>
-              <a:t>4/12/2025</a:t>
+              <a:t>4/13/2025</a:t>
             </a:fld>
             <a:endParaRPr lang="en-US"/>
           </a:p>
@@ -3263,7 +3263,7 @@
           <a:p>
             <a:fld id="{24E1524C-2386-4A77-AA3F-47DF77D98E67}" type="datetimeFigureOut">
               <a:rPr lang="en-US" smtClean="0"/>
-              <a:t>4/12/2025</a:t>
+              <a:t>4/13/2025</a:t>
             </a:fld>
             <a:endParaRPr lang="en-US"/>
           </a:p>
@@ -3538,7 +3538,7 @@
           <a:p>
             <a:fld id="{24E1524C-2386-4A77-AA3F-47DF77D98E67}" type="datetimeFigureOut">
               <a:rPr lang="en-US" smtClean="0"/>
-              <a:t>4/12/2025</a:t>
+              <a:t>4/13/2025</a:t>
             </a:fld>
             <a:endParaRPr lang="en-US"/>
           </a:p>
@@ -3790,7 +3790,7 @@
           <a:p>
             <a:fld id="{24E1524C-2386-4A77-AA3F-47DF77D98E67}" type="datetimeFigureOut">
               <a:rPr lang="en-US" smtClean="0"/>
-              <a:t>4/12/2025</a:t>
+              <a:t>4/13/2025</a:t>
             </a:fld>
             <a:endParaRPr lang="en-US"/>
           </a:p>
@@ -4001,7 +4001,7 @@
           <a:p>
             <a:fld id="{24E1524C-2386-4A77-AA3F-47DF77D98E67}" type="datetimeFigureOut">
               <a:rPr lang="en-US" smtClean="0"/>
-              <a:t>4/12/2025</a:t>
+              <a:t>4/13/2025</a:t>
             </a:fld>
             <a:endParaRPr lang="en-US"/>
           </a:p>
@@ -5816,53 +5816,6 @@
           </a:extLst>
         </p:spPr>
       </p:pic>
-      <p:pic>
-        <p:nvPicPr>
-          <p:cNvPr id="1028" name="Picture 4">
-            <a:extLst>
-              <a:ext uri="{FF2B5EF4-FFF2-40B4-BE49-F238E27FC236}">
-                <a16:creationId xmlns:a16="http://schemas.microsoft.com/office/drawing/2014/main" id="{8DF103DE-6389-BA7F-D188-D3E4AF826C43}"/>
-              </a:ext>
-            </a:extLst>
-          </p:cNvPr>
-          <p:cNvPicPr>
-            <a:picLocks noChangeAspect="1" noChangeArrowheads="1"/>
-          </p:cNvPicPr>
-          <p:nvPr/>
-        </p:nvPicPr>
-        <p:blipFill>
-          <a:blip r:embed="rId7">
-            <a:extLst>
-              <a:ext uri="{28A0092B-C50C-407E-A947-70E740481C1C}">
-                <a14:useLocalDpi xmlns:a14="http://schemas.microsoft.com/office/drawing/2010/main" val="0"/>
-              </a:ext>
-            </a:extLst>
-          </a:blip>
-          <a:srcRect/>
-          <a:stretch>
-            <a:fillRect/>
-          </a:stretch>
-        </p:blipFill>
-        <p:spPr bwMode="auto">
-          <a:xfrm>
-            <a:off x="1305626" y="27660600"/>
-            <a:ext cx="13777885" cy="3599031"/>
-          </a:xfrm>
-          <a:prstGeom prst="rect">
-            <a:avLst/>
-          </a:prstGeom>
-          <a:noFill/>
-          <a:extLst>
-            <a:ext uri="{909E8E84-426E-40DD-AFC4-6F175D3DCCD1}">
-              <a14:hiddenFill xmlns:a14="http://schemas.microsoft.com/office/drawing/2010/main">
-                <a:solidFill>
-                  <a:srgbClr val="FFFFFF"/>
-                </a:solidFill>
-              </a14:hiddenFill>
-            </a:ext>
-          </a:extLst>
-        </p:spPr>
-      </p:pic>
       <p:sp>
         <p:nvSpPr>
           <p:cNvPr id="4" name="TextBox 3">
@@ -6235,6 +6188,53 @@
           </a:p>
         </p:txBody>
       </p:sp>
+      <p:pic>
+        <p:nvPicPr>
+          <p:cNvPr id="10" name="Picture 2">
+            <a:extLst>
+              <a:ext uri="{FF2B5EF4-FFF2-40B4-BE49-F238E27FC236}">
+                <a16:creationId xmlns:a16="http://schemas.microsoft.com/office/drawing/2014/main" id="{346E2AB5-04DF-E41E-EBF3-1A6DFEC462DA}"/>
+              </a:ext>
+            </a:extLst>
+          </p:cNvPr>
+          <p:cNvPicPr>
+            <a:picLocks noChangeAspect="1" noChangeArrowheads="1"/>
+          </p:cNvPicPr>
+          <p:nvPr/>
+        </p:nvPicPr>
+        <p:blipFill>
+          <a:blip r:embed="rId7">
+            <a:extLst>
+              <a:ext uri="{28A0092B-C50C-407E-A947-70E740481C1C}">
+                <a14:useLocalDpi xmlns:a14="http://schemas.microsoft.com/office/drawing/2010/main" val="0"/>
+              </a:ext>
+            </a:extLst>
+          </a:blip>
+          <a:srcRect/>
+          <a:stretch>
+            <a:fillRect/>
+          </a:stretch>
+        </p:blipFill>
+        <p:spPr bwMode="auto">
+          <a:xfrm>
+            <a:off x="737142" y="28149712"/>
+            <a:ext cx="14824396" cy="2827088"/>
+          </a:xfrm>
+          <a:prstGeom prst="rect">
+            <a:avLst/>
+          </a:prstGeom>
+          <a:noFill/>
+          <a:extLst>
+            <a:ext uri="{909E8E84-426E-40DD-AFC4-6F175D3DCCD1}">
+              <a14:hiddenFill xmlns:a14="http://schemas.microsoft.com/office/drawing/2010/main">
+                <a:solidFill>
+                  <a:srgbClr val="FFFFFF"/>
+                </a:solidFill>
+              </a14:hiddenFill>
+            </a:ext>
+          </a:extLst>
+        </p:spPr>
+      </p:pic>
     </p:spTree>
     <p:extLst>
       <p:ext uri="{BB962C8B-B14F-4D97-AF65-F5344CB8AC3E}">
@@ -7159,15 +7159,6 @@
 </file>
 
 <file path=customXml/item2.xml><?xml version="1.0" encoding="utf-8"?>
-<?mso-contentType ?>
-<FormTemplates xmlns="http://schemas.microsoft.com/sharepoint/v3/contenttype/forms">
-  <Display>DocumentLibraryForm</Display>
-  <Edit>DocumentLibraryForm</Edit>
-  <New>DocumentLibraryForm</New>
-</FormTemplates>
-</file>
-
-<file path=customXml/item3.xml><?xml version="1.0" encoding="utf-8"?>
 <ct:contentTypeSchema xmlns:ct="http://schemas.microsoft.com/office/2006/metadata/contentType" xmlns:ma="http://schemas.microsoft.com/office/2006/metadata/properties/metaAttributes" ct:_="" ma:_="" ma:contentTypeName="Document" ma:contentTypeID="0x010100896936867FB4BD4CBBB1D9655E335B32" ma:contentTypeVersion="38" ma:contentTypeDescription="Create a new document." ma:contentTypeScope="" ma:versionID="361c3cd5f1c98f95f9d571e756a51304">
   <xsd:schema xmlns:xsd="http://www.w3.org/2001/XMLSchema" xmlns:xs="http://www.w3.org/2001/XMLSchema" xmlns:p="http://schemas.microsoft.com/office/2006/metadata/properties" xmlns:ns2="251e4a2b-1a33-4513-9017-f0bb34cca31e" xmlns:ns3="8380694e-df13-4765-9f36-450494b12df9" xmlns:ns4="e9952153-5aa5-42e8-8300-ccc6398e6c31" targetNamespace="http://schemas.microsoft.com/office/2006/metadata/properties" ma:root="true" ma:fieldsID="2a7a4d7a194afafab4501530be61863a" ns2:_="" ns3:_="" ns4:_="">
     <xsd:import namespace="251e4a2b-1a33-4513-9017-f0bb34cca31e"/>
@@ -7609,6 +7600,15 @@
 </ct:contentTypeSchema>
 </file>
 
+<file path=customXml/item3.xml><?xml version="1.0" encoding="utf-8"?>
+<?mso-contentType ?>
+<FormTemplates xmlns="http://schemas.microsoft.com/sharepoint/v3/contenttype/forms">
+  <Display>DocumentLibraryForm</Display>
+  <Edit>DocumentLibraryForm</Edit>
+  <New>DocumentLibraryForm</New>
+</FormTemplates>
+</file>
+
 <file path=customXml/itemProps1.xml><?xml version="1.0" encoding="utf-8"?>
 <ds:datastoreItem xmlns:ds="http://schemas.openxmlformats.org/officeDocument/2006/customXml" ds:itemID="{EA5F3152-1B22-4120-90AD-ABECC3E883B9}">
   <ds:schemaRefs>
@@ -7628,14 +7628,6 @@
 </file>
 
 <file path=customXml/itemProps2.xml><?xml version="1.0" encoding="utf-8"?>
-<ds:datastoreItem xmlns:ds="http://schemas.openxmlformats.org/officeDocument/2006/customXml" ds:itemID="{72B731D7-F5BF-4D0E-BEA0-A10CED407C8E}">
-  <ds:schemaRefs>
-    <ds:schemaRef ds:uri="http://schemas.microsoft.com/sharepoint/v3/contenttype/forms"/>
-  </ds:schemaRefs>
-</ds:datastoreItem>
-</file>
-
-<file path=customXml/itemProps3.xml><?xml version="1.0" encoding="utf-8"?>
 <ds:datastoreItem xmlns:ds="http://schemas.openxmlformats.org/officeDocument/2006/customXml" ds:itemID="{7717D36E-5DB5-4546-9539-BCB69F065F47}">
   <ds:schemaRefs>
     <ds:schemaRef ds:uri="http://schemas.microsoft.com/office/2006/metadata/contentType"/>
@@ -7653,4 +7645,12 @@
     <ds:schemaRef ds:uri="http://schemas.microsoft.com/internal/obd"/>
   </ds:schemaRefs>
 </ds:datastoreItem>
+</file>
+
+<file path=customXml/itemProps3.xml><?xml version="1.0" encoding="utf-8"?>
+<ds:datastoreItem xmlns:ds="http://schemas.openxmlformats.org/officeDocument/2006/customXml" ds:itemID="{72B731D7-F5BF-4D0E-BEA0-A10CED407C8E}">
+  <ds:schemaRefs>
+    <ds:schemaRef ds:uri="http://schemas.microsoft.com/sharepoint/v3/contenttype/forms"/>
+  </ds:schemaRefs>
+</ds:datastoreItem>
 </file>
</xml_diff>